<commit_message>
Rename the service to 뷰티 스타일 AI 분석 everywhere
Site (review, notice pages, copy text, order image, JSON generator), README and
Space title, report and its PDF, model card, presentation notes and slides,
legal drafts. Particles adjusted for the new final consonant.

Co-Authored-By: Claude Opus 5.5 <noreply@anthropic.com>
Claude-Session: https://claude.ai/code/session_01XARMjX5bykpa3wQR5XZuyC
</commit_message>
<xml_diff>
--- a/docs/presentation.pptx
+++ b/docs/presentation.pptx
@@ -117,20 +117,20 @@
   <p:extLst>
     <p:ext uri="{521415D9-36F7-43E2-AB2F-B90AF26B5E84}">
       <p14:sectionLst xmlns:p14="http://schemas.microsoft.com/office/powerpoint/2010/main">
-        <p14:section name="도입" id="{0fd2cfab-4ce5-ac32-e415-361c8d970679}">
+        <p14:section name="도입" id="{04b96e1f-02b1-c460-820f-6ab81763ec01}">
           <p14:sldIdLst>
             <p14:sldId id="256"/>
             <p14:sldId id="257"/>
             <p14:sldId id="258"/>
           </p14:sldIdLst>
         </p14:section>
-        <p14:section name="결과 화면" id="{0a4198e3-4326-d0ad-5a84-0871922e9a31}">
+        <p14:section name="결과 화면" id="{c1ba3fdd-760b-c11b-1f98-0b9df76323f2}">
           <p14:sldIdLst>
             <p14:sldId id="259"/>
             <p14:sldId id="260"/>
           </p14:sldIdLst>
         </p14:section>
-        <p14:section name="동작 방식과 성능" id="{6708daed-f608-9547-bef1-6b206e37572b}">
+        <p14:section name="동작 방식과 성능" id="{27331b8c-31f7-9593-3b07-bdeef99644c6}">
           <p14:sldIdLst>
             <p14:sldId id="261"/>
             <p14:sldId id="262"/>
@@ -138,7 +138,7 @@
             <p14:sldId id="264"/>
           </p14:sldIdLst>
         </p14:section>
-        <p14:section name="마무리" id="{d94e7539-e0d3-746a-d4d2-6655b06ac6ce}">
+        <p14:section name="마무리" id="{63445476-bafc-b2f0-e9c2-9e7a1a5f4527}">
           <p14:sldIdLst>
             <p14:sldId id="265"/>
             <p14:sldId id="266"/>
@@ -1024,7 +1024,7 @@
           <a:p>
             <a:r>
               <a:rPr lang="en-US" dirty="0"/>
-              <a:t>안녕하세요. 사진 한 장으로 헤어, 네일, 메이크업, 타투 스타일을 한국어로 설명해 주는 뷰티 스타일 AI 설명기를 발표하겠습니다. 오른쪽이 실제 화면입니다.</a:t>
+              <a:t>안녕하세요. 사진 한 장으로 헤어, 네일, 메이크업, 타투 스타일을 한국어로 설명해 주는 뷰티 스타일 AI 분석을 발표하겠습니다. 오른쪽이 실제 화면입니다.</a:t>
             </a:r>
             <a:endParaRPr lang="en-US" dirty="0"/>
           </a:p>
@@ -2194,7 +2194,7 @@
                   <a:schemeClr val="accent4"/>
                 </a:solidFill>
               </a:rPr>
-              <a:t>뷰티 스타일 AI 설명기</a:t>
+              <a:t>뷰티 스타일 AI 분석</a:t>
             </a:r>
             <a:endParaRPr lang="en-US" sz="1100" dirty="0"/>
           </a:p>
@@ -2354,7 +2354,7 @@
                   <a:schemeClr val="accent4"/>
                 </a:solidFill>
               </a:rPr>
-              <a:t>뷰티 스타일 AI 설명기</a:t>
+              <a:t>뷰티 스타일 AI 분석</a:t>
             </a:r>
             <a:endParaRPr lang="en-US" sz="1100" dirty="0"/>
           </a:p>
@@ -2935,7 +2935,7 @@
                   <a:schemeClr val="tx1"/>
                 </a:solidFill>
               </a:rPr>
-              <a:t>AI 설명기</a:t>
+              <a:t>AI 분석</a:t>
             </a:r>
             <a:endParaRPr lang="ko-KR" sz="6000" dirty="0"/>
           </a:p>
@@ -3010,7 +3010,7 @@
                   <a:schemeClr val="accent4"/>
                 </a:solidFill>
               </a:rPr>
-              <a:t>[발표자 이름 · 학번] · 2026. 10. 8.</a:t>
+              <a:t>인공지능 소프트웨어 / 오경민</a:t>
             </a:r>
             <a:endParaRPr lang="ko-KR" sz="1400" dirty="0"/>
           </a:p>
@@ -3018,7 +3018,7 @@
       </p:sp>
       <p:pic>
         <p:nvPicPr>
-          <p:cNvPr id="5" name="shot-3" descr="뷰티 스타일 AI 설명기 분석 화면: 긴 머리 사진 옆에 레이어드컷 + S컬펌 장르와 설명이 나온 모습">    </p:cNvPr>
+          <p:cNvPr id="5" name="shot-3" descr="뷰티 스타일 AI 분석 화면: 긴 머리 사진 옆에 레이어드컷 + S컬펌 장르와 설명이 나온 모습">    </p:cNvPr>
           <p:cNvPicPr>
             <a:picLocks noChangeAspect="1"/>
           </p:cNvPicPr>
@@ -3702,7 +3702,7 @@
                   <a:schemeClr val="accent4"/>
                 </a:solidFill>
               </a:rPr>
-              <a:t>[발표자 이름 · 학번]</a:t>
+              <a:t>인공지능 소프트웨어 / 오경민</a:t>
             </a:r>
             <a:endParaRPr lang="ko-KR" sz="1400" dirty="0"/>
           </a:p>

</xml_diff>